<commit_message>
Update FEA project files and simulation parameters
Added node numbering figure and project zip archive. Updated geometry_2d.py to use a 5x5 grid with new spacing. Added debug print statements in matrices_2d.py. Overhauled simulation setup and boundary conditions in solve_2d_heat.py for clarity and new test case. Modified HW7/problem3a.py to use new triangle points and print only relevant matrix for Poisson problem.
</commit_message>
<xml_diff>
--- a/FEA/Final_Project/Final_Presentation.pptx
+++ b/FEA/Final_Project/Final_Presentation.pptx
@@ -14,12 +14,13 @@
     <p:sldId id="262" r:id="rId8"/>
     <p:sldId id="263" r:id="rId9"/>
     <p:sldId id="265" r:id="rId10"/>
-    <p:sldId id="264" r:id="rId11"/>
-    <p:sldId id="266" r:id="rId12"/>
-    <p:sldId id="267" r:id="rId13"/>
-    <p:sldId id="268" r:id="rId14"/>
-    <p:sldId id="269" r:id="rId15"/>
-    <p:sldId id="270" r:id="rId16"/>
+    <p:sldId id="271" r:id="rId11"/>
+    <p:sldId id="264" r:id="rId12"/>
+    <p:sldId id="266" r:id="rId13"/>
+    <p:sldId id="267" r:id="rId14"/>
+    <p:sldId id="268" r:id="rId15"/>
+    <p:sldId id="269" r:id="rId16"/>
+    <p:sldId id="270" r:id="rId17"/>
   </p:sldIdLst>
   <p:sldSz cx="12192000" cy="6858000"/>
   <p:notesSz cx="6858000" cy="9144000"/>
@@ -118,6 +119,11 @@
       </a:defRPr>
     </a:lvl9pPr>
   </p:defaultTextStyle>
+  <p:extLst>
+    <p:ext uri="{EFAFB233-063F-42B5-8137-9DF3F51BA10A}">
+      <p15:sldGuideLst xmlns:p15="http://schemas.microsoft.com/office/powerpoint/2012/main"/>
+    </p:ext>
+  </p:extLst>
 </p:presentation>
 </file>
 
@@ -268,7 +274,7 @@
           <a:p>
             <a:fld id="{FE92FF77-3009-4D37-AAB0-5ABA1BA1C47E}" type="datetimeFigureOut">
               <a:rPr lang="en-US" smtClean="0"/>
-              <a:t>11/25/2025</a:t>
+              <a:t>12/3/2025</a:t>
             </a:fld>
             <a:endParaRPr lang="en-US"/>
           </a:p>
@@ -466,7 +472,7 @@
           <a:p>
             <a:fld id="{FE92FF77-3009-4D37-AAB0-5ABA1BA1C47E}" type="datetimeFigureOut">
               <a:rPr lang="en-US" smtClean="0"/>
-              <a:t>11/25/2025</a:t>
+              <a:t>12/3/2025</a:t>
             </a:fld>
             <a:endParaRPr lang="en-US"/>
           </a:p>
@@ -674,7 +680,7 @@
           <a:p>
             <a:fld id="{FE92FF77-3009-4D37-AAB0-5ABA1BA1C47E}" type="datetimeFigureOut">
               <a:rPr lang="en-US" smtClean="0"/>
-              <a:t>11/25/2025</a:t>
+              <a:t>12/3/2025</a:t>
             </a:fld>
             <a:endParaRPr lang="en-US"/>
           </a:p>
@@ -872,7 +878,7 @@
           <a:p>
             <a:fld id="{FE92FF77-3009-4D37-AAB0-5ABA1BA1C47E}" type="datetimeFigureOut">
               <a:rPr lang="en-US" smtClean="0"/>
-              <a:t>11/25/2025</a:t>
+              <a:t>12/3/2025</a:t>
             </a:fld>
             <a:endParaRPr lang="en-US"/>
           </a:p>
@@ -1147,7 +1153,7 @@
           <a:p>
             <a:fld id="{FE92FF77-3009-4D37-AAB0-5ABA1BA1C47E}" type="datetimeFigureOut">
               <a:rPr lang="en-US" smtClean="0"/>
-              <a:t>11/25/2025</a:t>
+              <a:t>12/3/2025</a:t>
             </a:fld>
             <a:endParaRPr lang="en-US"/>
           </a:p>
@@ -1412,7 +1418,7 @@
           <a:p>
             <a:fld id="{FE92FF77-3009-4D37-AAB0-5ABA1BA1C47E}" type="datetimeFigureOut">
               <a:rPr lang="en-US" smtClean="0"/>
-              <a:t>11/25/2025</a:t>
+              <a:t>12/3/2025</a:t>
             </a:fld>
             <a:endParaRPr lang="en-US"/>
           </a:p>
@@ -1824,7 +1830,7 @@
           <a:p>
             <a:fld id="{FE92FF77-3009-4D37-AAB0-5ABA1BA1C47E}" type="datetimeFigureOut">
               <a:rPr lang="en-US" smtClean="0"/>
-              <a:t>11/25/2025</a:t>
+              <a:t>12/3/2025</a:t>
             </a:fld>
             <a:endParaRPr lang="en-US"/>
           </a:p>
@@ -1965,7 +1971,7 @@
           <a:p>
             <a:fld id="{FE92FF77-3009-4D37-AAB0-5ABA1BA1C47E}" type="datetimeFigureOut">
               <a:rPr lang="en-US" smtClean="0"/>
-              <a:t>11/25/2025</a:t>
+              <a:t>12/3/2025</a:t>
             </a:fld>
             <a:endParaRPr lang="en-US"/>
           </a:p>
@@ -2078,7 +2084,7 @@
           <a:p>
             <a:fld id="{FE92FF77-3009-4D37-AAB0-5ABA1BA1C47E}" type="datetimeFigureOut">
               <a:rPr lang="en-US" smtClean="0"/>
-              <a:t>11/25/2025</a:t>
+              <a:t>12/3/2025</a:t>
             </a:fld>
             <a:endParaRPr lang="en-US"/>
           </a:p>
@@ -2389,7 +2395,7 @@
           <a:p>
             <a:fld id="{FE92FF77-3009-4D37-AAB0-5ABA1BA1C47E}" type="datetimeFigureOut">
               <a:rPr lang="en-US" smtClean="0"/>
-              <a:t>11/25/2025</a:t>
+              <a:t>12/3/2025</a:t>
             </a:fld>
             <a:endParaRPr lang="en-US"/>
           </a:p>
@@ -2677,7 +2683,7 @@
           <a:p>
             <a:fld id="{FE92FF77-3009-4D37-AAB0-5ABA1BA1C47E}" type="datetimeFigureOut">
               <a:rPr lang="en-US" smtClean="0"/>
-              <a:t>11/25/2025</a:t>
+              <a:t>12/3/2025</a:t>
             </a:fld>
             <a:endParaRPr lang="en-US"/>
           </a:p>
@@ -2918,7 +2924,7 @@
           <a:p>
             <a:fld id="{FE92FF77-3009-4D37-AAB0-5ABA1BA1C47E}" type="datetimeFigureOut">
               <a:rPr lang="en-US" smtClean="0"/>
-              <a:t>11/25/2025</a:t>
+              <a:t>12/3/2025</a:t>
             </a:fld>
             <a:endParaRPr lang="en-US"/>
           </a:p>
@@ -3414,6 +3420,329 @@
         <p:cNvPr id="1" name="">
           <a:extLst>
             <a:ext uri="{FF2B5EF4-FFF2-40B4-BE49-F238E27FC236}">
+              <a16:creationId xmlns:a16="http://schemas.microsoft.com/office/drawing/2014/main" id="{E930F7FB-456B-1527-4DC4-96E164CAAECF}"/>
+            </a:ext>
+          </a:extLst>
+        </p:cNvPr>
+        <p:cNvGrpSpPr/>
+        <p:nvPr/>
+      </p:nvGrpSpPr>
+      <p:grpSpPr>
+        <a:xfrm>
+          <a:off x="0" y="0"/>
+          <a:ext cx="0" cy="0"/>
+          <a:chOff x="0" y="0"/>
+          <a:chExt cx="0" cy="0"/>
+        </a:xfrm>
+      </p:grpSpPr>
+      <p:pic>
+        <p:nvPicPr>
+          <p:cNvPr id="6" name="Content Placeholder 5">
+            <a:extLst>
+              <a:ext uri="{FF2B5EF4-FFF2-40B4-BE49-F238E27FC236}">
+                <a16:creationId xmlns:a16="http://schemas.microsoft.com/office/drawing/2014/main" id="{1D27DD20-9ABF-BA3B-7300-397F459EEDCA}"/>
+              </a:ext>
+            </a:extLst>
+          </p:cNvPr>
+          <p:cNvPicPr>
+            <a:picLocks noGrp="1" noChangeAspect="1"/>
+          </p:cNvPicPr>
+          <p:nvPr>
+            <p:ph idx="1"/>
+          </p:nvPr>
+        </p:nvPicPr>
+        <p:blipFill>
+          <a:blip r:embed="rId2"/>
+          <a:srcRect b="11683"/>
+          <a:stretch>
+            <a:fillRect/>
+          </a:stretch>
+        </p:blipFill>
+        <p:spPr>
+          <a:xfrm>
+            <a:off x="7677613" y="1335724"/>
+            <a:ext cx="4770808" cy="4907718"/>
+          </a:xfrm>
+          <a:prstGeom prst="rect">
+            <a:avLst/>
+          </a:prstGeom>
+        </p:spPr>
+      </p:pic>
+      <p:sp>
+        <p:nvSpPr>
+          <p:cNvPr id="2" name="Title 1">
+            <a:extLst>
+              <a:ext uri="{FF2B5EF4-FFF2-40B4-BE49-F238E27FC236}">
+                <a16:creationId xmlns:a16="http://schemas.microsoft.com/office/drawing/2014/main" id="{88E0EF76-E8E8-8895-E8BC-FFC256F6FC55}"/>
+              </a:ext>
+            </a:extLst>
+          </p:cNvPr>
+          <p:cNvSpPr>
+            <a:spLocks noGrp="1"/>
+          </p:cNvSpPr>
+          <p:nvPr>
+            <p:ph type="title"/>
+          </p:nvPr>
+        </p:nvSpPr>
+        <p:spPr/>
+        <p:txBody>
+          <a:bodyPr/>
+          <a:lstStyle/>
+          <a:p>
+            <a:r>
+              <a:rPr lang="en-US" dirty="0"/>
+              <a:t>2D Transient Poisson – Boundary integral </a:t>
+            </a:r>
+          </a:p>
+        </p:txBody>
+      </p:sp>
+      <p:pic>
+        <p:nvPicPr>
+          <p:cNvPr id="10" name="Picture 9">
+            <a:extLst>
+              <a:ext uri="{FF2B5EF4-FFF2-40B4-BE49-F238E27FC236}">
+                <a16:creationId xmlns:a16="http://schemas.microsoft.com/office/drawing/2014/main" id="{63E9E4BA-1A9D-349D-68AD-AA2B450D25D9}"/>
+              </a:ext>
+            </a:extLst>
+          </p:cNvPr>
+          <p:cNvPicPr>
+            <a:picLocks noChangeAspect="1"/>
+          </p:cNvPicPr>
+          <p:nvPr/>
+        </p:nvPicPr>
+        <p:blipFill>
+          <a:blip r:embed="rId3"/>
+          <a:stretch>
+            <a:fillRect/>
+          </a:stretch>
+        </p:blipFill>
+        <p:spPr>
+          <a:xfrm>
+            <a:off x="380152" y="2929238"/>
+            <a:ext cx="6049219" cy="1105054"/>
+          </a:xfrm>
+          <a:prstGeom prst="rect">
+            <a:avLst/>
+          </a:prstGeom>
+        </p:spPr>
+      </p:pic>
+      <p:sp>
+        <p:nvSpPr>
+          <p:cNvPr id="15" name="Freeform: Shape 14">
+            <a:extLst>
+              <a:ext uri="{FF2B5EF4-FFF2-40B4-BE49-F238E27FC236}">
+                <a16:creationId xmlns:a16="http://schemas.microsoft.com/office/drawing/2014/main" id="{B68CDDF1-08F8-3184-7CA9-F5E65FEA46E7}"/>
+              </a:ext>
+            </a:extLst>
+          </p:cNvPr>
+          <p:cNvSpPr/>
+          <p:nvPr/>
+        </p:nvSpPr>
+        <p:spPr>
+          <a:xfrm>
+            <a:off x="2562131" y="1556159"/>
+            <a:ext cx="5875699" cy="1558233"/>
+          </a:xfrm>
+          <a:custGeom>
+            <a:avLst/>
+            <a:gdLst>
+              <a:gd name="connsiteX0" fmla="*/ 5875699 w 5875699"/>
+              <a:gd name="connsiteY0" fmla="*/ 1368110 h 1558233"/>
+              <a:gd name="connsiteX1" fmla="*/ 2833734 w 5875699"/>
+              <a:gd name="connsiteY1" fmla="*/ 1037 h 1558233"/>
+              <a:gd name="connsiteX2" fmla="*/ 0 w 5875699"/>
+              <a:gd name="connsiteY2" fmla="*/ 1558233 h 1558233"/>
+            </a:gdLst>
+            <a:ahLst/>
+            <a:cxnLst>
+              <a:cxn ang="0">
+                <a:pos x="connsiteX0" y="connsiteY0"/>
+              </a:cxn>
+              <a:cxn ang="0">
+                <a:pos x="connsiteX1" y="connsiteY1"/>
+              </a:cxn>
+              <a:cxn ang="0">
+                <a:pos x="connsiteX2" y="connsiteY2"/>
+              </a:cxn>
+            </a:cxnLst>
+            <a:rect l="l" t="t" r="r" b="b"/>
+            <a:pathLst>
+              <a:path w="5875699" h="1558233">
+                <a:moveTo>
+                  <a:pt x="5875699" y="1368110"/>
+                </a:moveTo>
+                <a:cubicBezTo>
+                  <a:pt x="4844358" y="668730"/>
+                  <a:pt x="3813017" y="-30650"/>
+                  <a:pt x="2833734" y="1037"/>
+                </a:cubicBezTo>
+                <a:cubicBezTo>
+                  <a:pt x="1854451" y="32724"/>
+                  <a:pt x="927225" y="795478"/>
+                  <a:pt x="0" y="1558233"/>
+                </a:cubicBezTo>
+              </a:path>
+            </a:pathLst>
+          </a:custGeom>
+          <a:noFill/>
+          <a:ln>
+            <a:solidFill>
+              <a:schemeClr val="accent5">
+                <a:lumMod val="75000"/>
+              </a:schemeClr>
+            </a:solidFill>
+            <a:headEnd type="none" w="med" len="med"/>
+            <a:tailEnd type="arrow" w="med" len="med"/>
+          </a:ln>
+        </p:spPr>
+        <p:style>
+          <a:lnRef idx="2">
+            <a:schemeClr val="accent1">
+              <a:shade val="15000"/>
+            </a:schemeClr>
+          </a:lnRef>
+          <a:fillRef idx="1">
+            <a:schemeClr val="accent1"/>
+          </a:fillRef>
+          <a:effectRef idx="0">
+            <a:schemeClr val="accent1"/>
+          </a:effectRef>
+          <a:fontRef idx="minor">
+            <a:schemeClr val="lt1"/>
+          </a:fontRef>
+        </p:style>
+        <p:txBody>
+          <a:bodyPr rtlCol="0" anchor="ctr"/>
+          <a:lstStyle/>
+          <a:p>
+            <a:pPr algn="ctr"/>
+            <a:endParaRPr lang="en-US"/>
+          </a:p>
+        </p:txBody>
+      </p:sp>
+      <p:sp>
+        <p:nvSpPr>
+          <p:cNvPr id="17" name="Freeform: Shape 16">
+            <a:extLst>
+              <a:ext uri="{FF2B5EF4-FFF2-40B4-BE49-F238E27FC236}">
+                <a16:creationId xmlns:a16="http://schemas.microsoft.com/office/drawing/2014/main" id="{44E3D64F-CE56-D970-7598-561D42687DD2}"/>
+              </a:ext>
+            </a:extLst>
+          </p:cNvPr>
+          <p:cNvSpPr/>
+          <p:nvPr/>
+        </p:nvSpPr>
+        <p:spPr>
+          <a:xfrm>
+            <a:off x="4888871" y="4010685"/>
+            <a:ext cx="3657600" cy="1055056"/>
+          </a:xfrm>
+          <a:custGeom>
+            <a:avLst/>
+            <a:gdLst>
+              <a:gd name="connsiteX0" fmla="*/ 3657600 w 3657600"/>
+              <a:gd name="connsiteY0" fmla="*/ 615636 h 1055056"/>
+              <a:gd name="connsiteX1" fmla="*/ 1611517 w 3657600"/>
+              <a:gd name="connsiteY1" fmla="*/ 1032095 h 1055056"/>
+              <a:gd name="connsiteX2" fmla="*/ 0 w 3657600"/>
+              <a:gd name="connsiteY2" fmla="*/ 0 h 1055056"/>
+              <a:gd name="connsiteX3" fmla="*/ 0 w 3657600"/>
+              <a:gd name="connsiteY3" fmla="*/ 0 h 1055056"/>
+            </a:gdLst>
+            <a:ahLst/>
+            <a:cxnLst>
+              <a:cxn ang="0">
+                <a:pos x="connsiteX0" y="connsiteY0"/>
+              </a:cxn>
+              <a:cxn ang="0">
+                <a:pos x="connsiteX1" y="connsiteY1"/>
+              </a:cxn>
+              <a:cxn ang="0">
+                <a:pos x="connsiteX2" y="connsiteY2"/>
+              </a:cxn>
+              <a:cxn ang="0">
+                <a:pos x="connsiteX3" y="connsiteY3"/>
+              </a:cxn>
+            </a:cxnLst>
+            <a:rect l="l" t="t" r="r" b="b"/>
+            <a:pathLst>
+              <a:path w="3657600" h="1055056">
+                <a:moveTo>
+                  <a:pt x="3657600" y="615636"/>
+                </a:moveTo>
+                <a:cubicBezTo>
+                  <a:pt x="2939358" y="875168"/>
+                  <a:pt x="2221117" y="1134701"/>
+                  <a:pt x="1611517" y="1032095"/>
+                </a:cubicBezTo>
+                <a:cubicBezTo>
+                  <a:pt x="1001917" y="929489"/>
+                  <a:pt x="0" y="0"/>
+                  <a:pt x="0" y="0"/>
+                </a:cubicBezTo>
+                <a:lnTo>
+                  <a:pt x="0" y="0"/>
+                </a:lnTo>
+              </a:path>
+            </a:pathLst>
+          </a:custGeom>
+          <a:noFill/>
+          <a:ln>
+            <a:solidFill>
+              <a:schemeClr val="accent6">
+                <a:lumMod val="75000"/>
+              </a:schemeClr>
+            </a:solidFill>
+            <a:headEnd type="none" w="med" len="med"/>
+            <a:tailEnd type="arrow" w="med" len="med"/>
+          </a:ln>
+        </p:spPr>
+        <p:style>
+          <a:lnRef idx="2">
+            <a:schemeClr val="accent1">
+              <a:shade val="15000"/>
+            </a:schemeClr>
+          </a:lnRef>
+          <a:fillRef idx="1">
+            <a:schemeClr val="accent1"/>
+          </a:fillRef>
+          <a:effectRef idx="0">
+            <a:schemeClr val="accent1"/>
+          </a:effectRef>
+          <a:fontRef idx="minor">
+            <a:schemeClr val="lt1"/>
+          </a:fontRef>
+        </p:style>
+        <p:txBody>
+          <a:bodyPr rtlCol="0" anchor="ctr"/>
+          <a:lstStyle/>
+          <a:p>
+            <a:pPr algn="ctr"/>
+            <a:endParaRPr lang="en-US"/>
+          </a:p>
+        </p:txBody>
+      </p:sp>
+    </p:spTree>
+    <p:extLst>
+      <p:ext uri="{BB962C8B-B14F-4D97-AF65-F5344CB8AC3E}">
+        <p14:creationId xmlns:p14="http://schemas.microsoft.com/office/powerpoint/2010/main" val="3457821068"/>
+      </p:ext>
+    </p:extLst>
+  </p:cSld>
+  <p:clrMapOvr>
+    <a:masterClrMapping/>
+  </p:clrMapOvr>
+</p:sld>
+</file>
+
+<file path=ppt/slides/slide11.xml><?xml version="1.0" encoding="utf-8"?>
+<p:sld xmlns:a="http://schemas.openxmlformats.org/drawingml/2006/main" xmlns:r="http://schemas.openxmlformats.org/officeDocument/2006/relationships" xmlns:p="http://schemas.openxmlformats.org/presentationml/2006/main">
+  <p:cSld>
+    <p:spTree>
+      <p:nvGrpSpPr>
+        <p:cNvPr id="1" name="">
+          <a:extLst>
+            <a:ext uri="{FF2B5EF4-FFF2-40B4-BE49-F238E27FC236}">
               <a16:creationId xmlns:a16="http://schemas.microsoft.com/office/drawing/2014/main" id="{71BD0BFC-C247-F3DC-D6B3-06CD54D86858}"/>
             </a:ext>
           </a:extLst>
@@ -3431,65 +3760,34 @@
       </p:grpSpPr>
       <p:pic>
         <p:nvPicPr>
-          <p:cNvPr id="6" name="Content Placeholder 5">
-            <a:extLst>
-              <a:ext uri="{FF2B5EF4-FFF2-40B4-BE49-F238E27FC236}">
-                <a16:creationId xmlns:a16="http://schemas.microsoft.com/office/drawing/2014/main" id="{0A3DD47F-7978-E5E2-2828-15D87E524FBB}"/>
+          <p:cNvPr id="10" name="Picture 9">
+            <a:extLst>
+              <a:ext uri="{FF2B5EF4-FFF2-40B4-BE49-F238E27FC236}">
+                <a16:creationId xmlns:a16="http://schemas.microsoft.com/office/drawing/2014/main" id="{8F1EF755-6B03-BADA-9DD9-1DAF9ECAFA92}"/>
               </a:ext>
             </a:extLst>
           </p:cNvPr>
           <p:cNvPicPr>
-            <a:picLocks noGrp="1" noChangeAspect="1"/>
+            <a:picLocks noChangeAspect="1"/>
           </p:cNvPicPr>
-          <p:nvPr>
-            <p:ph idx="1"/>
-          </p:nvPr>
+          <p:nvPr/>
         </p:nvPicPr>
         <p:blipFill>
           <a:blip r:embed="rId2"/>
-          <a:srcRect b="11683"/>
           <a:stretch>
             <a:fillRect/>
           </a:stretch>
         </p:blipFill>
         <p:spPr>
           <a:xfrm>
-            <a:off x="275" y="935923"/>
-            <a:ext cx="4770808" cy="4907718"/>
+            <a:off x="315802" y="2813099"/>
+            <a:ext cx="6049219" cy="1105054"/>
           </a:xfrm>
           <a:prstGeom prst="rect">
             <a:avLst/>
           </a:prstGeom>
         </p:spPr>
       </p:pic>
-      <p:sp>
-        <p:nvSpPr>
-          <p:cNvPr id="2" name="Title 1">
-            <a:extLst>
-              <a:ext uri="{FF2B5EF4-FFF2-40B4-BE49-F238E27FC236}">
-                <a16:creationId xmlns:a16="http://schemas.microsoft.com/office/drawing/2014/main" id="{66DEA36B-DAF2-2D69-16B4-528205A907AC}"/>
-              </a:ext>
-            </a:extLst>
-          </p:cNvPr>
-          <p:cNvSpPr>
-            <a:spLocks noGrp="1"/>
-          </p:cNvSpPr>
-          <p:nvPr>
-            <p:ph type="title"/>
-          </p:nvPr>
-        </p:nvSpPr>
-        <p:spPr/>
-        <p:txBody>
-          <a:bodyPr/>
-          <a:lstStyle/>
-          <a:p>
-            <a:r>
-              <a:rPr lang="en-US" dirty="0"/>
-              <a:t>2D Transient Poisson</a:t>
-            </a:r>
-          </a:p>
-        </p:txBody>
-      </p:sp>
       <p:pic>
         <p:nvPicPr>
           <p:cNvPr id="8" name="Picture 7">
@@ -3512,7 +3810,7 @@
         </p:blipFill>
         <p:spPr>
           <a:xfrm>
-            <a:off x="6096000" y="689843"/>
+            <a:off x="5978305" y="1027906"/>
             <a:ext cx="5677626" cy="5153798"/>
           </a:xfrm>
           <a:prstGeom prst="rect">
@@ -3520,36 +3818,34 @@
           </a:prstGeom>
         </p:spPr>
       </p:pic>
-      <p:pic>
-        <p:nvPicPr>
-          <p:cNvPr id="10" name="Picture 9">
-            <a:extLst>
-              <a:ext uri="{FF2B5EF4-FFF2-40B4-BE49-F238E27FC236}">
-                <a16:creationId xmlns:a16="http://schemas.microsoft.com/office/drawing/2014/main" id="{8F1EF755-6B03-BADA-9DD9-1DAF9ECAFA92}"/>
-              </a:ext>
-            </a:extLst>
-          </p:cNvPr>
-          <p:cNvPicPr>
-            <a:picLocks noChangeAspect="1"/>
-          </p:cNvPicPr>
-          <p:nvPr/>
-        </p:nvPicPr>
-        <p:blipFill>
-          <a:blip r:embed="rId4"/>
-          <a:stretch>
-            <a:fillRect/>
-          </a:stretch>
-        </p:blipFill>
-        <p:spPr>
-          <a:xfrm>
-            <a:off x="2805505" y="5752946"/>
-            <a:ext cx="6049219" cy="1105054"/>
-          </a:xfrm>
-          <a:prstGeom prst="rect">
-            <a:avLst/>
-          </a:prstGeom>
-        </p:spPr>
-      </p:pic>
+      <p:sp>
+        <p:nvSpPr>
+          <p:cNvPr id="2" name="Title 1">
+            <a:extLst>
+              <a:ext uri="{FF2B5EF4-FFF2-40B4-BE49-F238E27FC236}">
+                <a16:creationId xmlns:a16="http://schemas.microsoft.com/office/drawing/2014/main" id="{66DEA36B-DAF2-2D69-16B4-528205A907AC}"/>
+              </a:ext>
+            </a:extLst>
+          </p:cNvPr>
+          <p:cNvSpPr>
+            <a:spLocks noGrp="1"/>
+          </p:cNvSpPr>
+          <p:nvPr>
+            <p:ph type="title"/>
+          </p:nvPr>
+        </p:nvSpPr>
+        <p:spPr/>
+        <p:txBody>
+          <a:bodyPr/>
+          <a:lstStyle/>
+          <a:p>
+            <a:r>
+              <a:rPr lang="en-US" dirty="0"/>
+              <a:t>2D Transient Poisson Boundary integral </a:t>
+            </a:r>
+          </a:p>
+        </p:txBody>
+      </p:sp>
     </p:spTree>
     <p:extLst>
       <p:ext uri="{BB962C8B-B14F-4D97-AF65-F5344CB8AC3E}">
@@ -3563,7 +3859,7 @@
 </p:sld>
 </file>
 
-<file path=ppt/slides/slide11.xml><?xml version="1.0" encoding="utf-8"?>
+<file path=ppt/slides/slide12.xml><?xml version="1.0" encoding="utf-8"?>
 <p:sld xmlns:a="http://schemas.openxmlformats.org/drawingml/2006/main" xmlns:r="http://schemas.openxmlformats.org/officeDocument/2006/relationships" xmlns:p="http://schemas.openxmlformats.org/presentationml/2006/main">
   <p:cSld>
     <p:spTree>
@@ -3727,7 +4023,7 @@
 </p:sld>
 </file>
 
-<file path=ppt/slides/slide12.xml><?xml version="1.0" encoding="utf-8"?>
+<file path=ppt/slides/slide13.xml><?xml version="1.0" encoding="utf-8"?>
 <p:sld xmlns:a="http://schemas.openxmlformats.org/drawingml/2006/main" xmlns:r="http://schemas.openxmlformats.org/officeDocument/2006/relationships" xmlns:p="http://schemas.openxmlformats.org/presentationml/2006/main">
   <p:cSld>
     <p:spTree>
@@ -3778,8 +4074,8 @@
           </a:p>
         </p:txBody>
       </p:sp>
-      <mc:AlternateContent xmlns:mc="http://schemas.openxmlformats.org/markup-compatibility/2006">
-        <mc:Choice xmlns:a14="http://schemas.microsoft.com/office/drawing/2010/main" Requires="a14">
+      <mc:AlternateContent xmlns:mc="http://schemas.openxmlformats.org/markup-compatibility/2006" xmlns:a14="http://schemas.microsoft.com/office/drawing/2010/main">
+        <mc:Choice Requires="a14">
           <p:sp>
             <p:nvSpPr>
               <p:cNvPr id="4" name="Content Placeholder 3">
@@ -3854,7 +4150,7 @@
             </p:txBody>
           </p:sp>
         </mc:Choice>
-        <mc:Fallback>
+        <mc:Fallback xmlns="">
           <p:sp>
             <p:nvSpPr>
               <p:cNvPr id="4" name="Content Placeholder 3">
@@ -3937,7 +4233,7 @@
 </p:sld>
 </file>
 
-<file path=ppt/slides/slide13.xml><?xml version="1.0" encoding="utf-8"?>
+<file path=ppt/slides/slide14.xml><?xml version="1.0" encoding="utf-8"?>
 <p:sld xmlns:a="http://schemas.openxmlformats.org/drawingml/2006/main" xmlns:r="http://schemas.openxmlformats.org/officeDocument/2006/relationships" xmlns:p="http://schemas.openxmlformats.org/presentationml/2006/main">
   <p:cSld>
     <p:spTree>
@@ -4031,7 +4327,7 @@
 </p:sld>
 </file>
 
-<file path=ppt/slides/slide14.xml><?xml version="1.0" encoding="utf-8"?>
+<file path=ppt/slides/slide15.xml><?xml version="1.0" encoding="utf-8"?>
 <p:sld xmlns:a="http://schemas.openxmlformats.org/drawingml/2006/main" xmlns:r="http://schemas.openxmlformats.org/officeDocument/2006/relationships" xmlns:p="http://schemas.openxmlformats.org/presentationml/2006/main">
   <p:cSld>
     <p:spTree>
@@ -4121,7 +4417,7 @@
                 <a:pPr lvl="1"/>
                 <a:r>
                   <a:rPr lang="en-US" dirty="0"/>
-                  <a:t>Bottom constant heat flux of 1, Top variable heat flux of 5*x</a:t>
+                  <a:t>Top constant heat flux of 1, Bottom variable heat flux of 5*x</a:t>
                 </a:r>
               </a:p>
               <a:p>
@@ -4413,7 +4709,7 @@
 </p:sld>
 </file>
 
-<file path=ppt/slides/slide15.xml><?xml version="1.0" encoding="utf-8"?>
+<file path=ppt/slides/slide16.xml><?xml version="1.0" encoding="utf-8"?>
 <p:sld xmlns:a="http://schemas.openxmlformats.org/drawingml/2006/main" xmlns:r="http://schemas.openxmlformats.org/officeDocument/2006/relationships" xmlns:p="http://schemas.openxmlformats.org/presentationml/2006/main">
   <p:cSld>
     <p:spTree>
@@ -4466,7 +4762,7 @@
         </p:blipFill>
         <p:spPr>
           <a:xfrm>
-            <a:off x="1799924" y="547437"/>
+            <a:off x="1799924" y="67604"/>
             <a:ext cx="8414084" cy="6310563"/>
           </a:xfrm>
           <a:prstGeom prst="rect">
@@ -4476,33 +4772,140 @@
       </p:pic>
       <p:sp>
         <p:nvSpPr>
-          <p:cNvPr id="2" name="Title 1">
-            <a:extLst>
-              <a:ext uri="{FF2B5EF4-FFF2-40B4-BE49-F238E27FC236}">
-                <a16:creationId xmlns:a16="http://schemas.microsoft.com/office/drawing/2014/main" id="{EAB344C6-5A82-5DC1-2CA3-220ADC8AD871}"/>
-              </a:ext>
-            </a:extLst>
-          </p:cNvPr>
-          <p:cNvSpPr>
-            <a:spLocks noGrp="1"/>
-          </p:cNvSpPr>
-          <p:nvPr>
-            <p:ph type="title"/>
-          </p:nvPr>
+          <p:cNvPr id="5" name="TextBox 4">
+            <a:extLst>
+              <a:ext uri="{FF2B5EF4-FFF2-40B4-BE49-F238E27FC236}">
+                <a16:creationId xmlns:a16="http://schemas.microsoft.com/office/drawing/2014/main" id="{052D869B-1331-D3D3-E652-84CC881CA80F}"/>
+              </a:ext>
+            </a:extLst>
+          </p:cNvPr>
+          <p:cNvSpPr txBox="1"/>
+          <p:nvPr/>
         </p:nvSpPr>
         <p:spPr>
           <a:xfrm>
-            <a:off x="751573" y="0"/>
-            <a:ext cx="10515600" cy="1325563"/>
+            <a:off x="669956" y="2661719"/>
+            <a:ext cx="1484702" cy="369332"/>
           </a:xfrm>
+          <a:prstGeom prst="rect">
+            <a:avLst/>
+          </a:prstGeom>
+          <a:noFill/>
         </p:spPr>
         <p:txBody>
-          <a:bodyPr/>
+          <a:bodyPr wrap="none" rtlCol="0">
+            <a:spAutoFit/>
+          </a:bodyPr>
           <a:lstStyle/>
           <a:p>
             <a:r>
               <a:rPr lang="en-US" dirty="0"/>
-              <a:t>2D Transient Poisson</a:t>
+              <a:t>U=0 Dirichlet</a:t>
+            </a:r>
+          </a:p>
+        </p:txBody>
+      </p:sp>
+      <p:sp>
+        <p:nvSpPr>
+          <p:cNvPr id="7" name="TextBox 6">
+            <a:extLst>
+              <a:ext uri="{FF2B5EF4-FFF2-40B4-BE49-F238E27FC236}">
+                <a16:creationId xmlns:a16="http://schemas.microsoft.com/office/drawing/2014/main" id="{30A6688F-AB8F-DC55-FC85-0F10AD062991}"/>
+              </a:ext>
+            </a:extLst>
+          </p:cNvPr>
+          <p:cNvSpPr txBox="1"/>
+          <p:nvPr/>
+        </p:nvSpPr>
+        <p:spPr>
+          <a:xfrm>
+            <a:off x="9471657" y="3333386"/>
+            <a:ext cx="1484702" cy="369332"/>
+          </a:xfrm>
+          <a:prstGeom prst="rect">
+            <a:avLst/>
+          </a:prstGeom>
+          <a:noFill/>
+        </p:spPr>
+        <p:txBody>
+          <a:bodyPr wrap="none" rtlCol="0">
+            <a:spAutoFit/>
+          </a:bodyPr>
+          <a:lstStyle/>
+          <a:p>
+            <a:r>
+              <a:rPr lang="en-US" dirty="0"/>
+              <a:t>U=1 Dirichlet</a:t>
+            </a:r>
+          </a:p>
+        </p:txBody>
+      </p:sp>
+      <p:sp>
+        <p:nvSpPr>
+          <p:cNvPr id="8" name="TextBox 7">
+            <a:extLst>
+              <a:ext uri="{FF2B5EF4-FFF2-40B4-BE49-F238E27FC236}">
+                <a16:creationId xmlns:a16="http://schemas.microsoft.com/office/drawing/2014/main" id="{3720890C-33EC-F2CC-1EED-03BFD915D992}"/>
+              </a:ext>
+            </a:extLst>
+          </p:cNvPr>
+          <p:cNvSpPr txBox="1"/>
+          <p:nvPr/>
+        </p:nvSpPr>
+        <p:spPr>
+          <a:xfrm>
+            <a:off x="4986950" y="6193501"/>
+            <a:ext cx="1697901" cy="369332"/>
+          </a:xfrm>
+          <a:prstGeom prst="rect">
+            <a:avLst/>
+          </a:prstGeom>
+          <a:noFill/>
+        </p:spPr>
+        <p:txBody>
+          <a:bodyPr wrap="none" rtlCol="0">
+            <a:spAutoFit/>
+          </a:bodyPr>
+          <a:lstStyle/>
+          <a:p>
+            <a:r>
+              <a:rPr lang="en-US" dirty="0"/>
+              <a:t>q=5x Neumann</a:t>
+            </a:r>
+          </a:p>
+        </p:txBody>
+      </p:sp>
+      <p:sp>
+        <p:nvSpPr>
+          <p:cNvPr id="9" name="TextBox 8">
+            <a:extLst>
+              <a:ext uri="{FF2B5EF4-FFF2-40B4-BE49-F238E27FC236}">
+                <a16:creationId xmlns:a16="http://schemas.microsoft.com/office/drawing/2014/main" id="{3E85B458-37C7-20AF-E9F8-E1C7A4A89E65}"/>
+              </a:ext>
+            </a:extLst>
+          </p:cNvPr>
+          <p:cNvSpPr txBox="1"/>
+          <p:nvPr/>
+        </p:nvSpPr>
+        <p:spPr>
+          <a:xfrm>
+            <a:off x="5209311" y="133135"/>
+            <a:ext cx="1595309" cy="369332"/>
+          </a:xfrm>
+          <a:prstGeom prst="rect">
+            <a:avLst/>
+          </a:prstGeom>
+          <a:noFill/>
+        </p:spPr>
+        <p:txBody>
+          <a:bodyPr wrap="none" rtlCol="0">
+            <a:spAutoFit/>
+          </a:bodyPr>
+          <a:lstStyle/>
+          <a:p>
+            <a:r>
+              <a:rPr lang="en-US" dirty="0"/>
+              <a:t>q=1 Neumann</a:t>
             </a:r>
           </a:p>
         </p:txBody>
@@ -4672,8 +5075,8 @@
           <a:chExt cx="0" cy="0"/>
         </a:xfrm>
       </p:grpSpPr>
-      <mc:AlternateContent xmlns:mc="http://schemas.openxmlformats.org/markup-compatibility/2006">
-        <mc:Choice xmlns:a14="http://schemas.microsoft.com/office/drawing/2010/main" Requires="a14">
+      <mc:AlternateContent xmlns:mc="http://schemas.openxmlformats.org/markup-compatibility/2006" xmlns:a14="http://schemas.microsoft.com/office/drawing/2010/main">
+        <mc:Choice Requires="a14">
           <p:sp>
             <p:nvSpPr>
               <p:cNvPr id="2" name="Title 1">
@@ -4754,7 +5157,7 @@
             </p:txBody>
           </p:sp>
         </mc:Choice>
-        <mc:Fallback>
+        <mc:Fallback xmlns="">
           <p:sp>
             <p:nvSpPr>
               <p:cNvPr id="2" name="Title 1">
@@ -4947,8 +5350,8 @@
           </a:p>
         </p:txBody>
       </p:sp>
-      <mc:AlternateContent xmlns:mc="http://schemas.openxmlformats.org/markup-compatibility/2006">
-        <mc:Choice xmlns:a14="http://schemas.microsoft.com/office/drawing/2010/main" Requires="a14">
+      <mc:AlternateContent xmlns:mc="http://schemas.openxmlformats.org/markup-compatibility/2006" xmlns:a14="http://schemas.microsoft.com/office/drawing/2010/main">
+        <mc:Choice Requires="a14">
           <p:sp>
             <p:nvSpPr>
               <p:cNvPr id="4" name="TextBox 3">
@@ -4977,6 +5380,7 @@
               </a:bodyPr>
               <a:lstStyle/>
               <a:p>
+                <a:pPr/>
                 <a14:m>
                   <m:oMathPara xmlns:m="http://schemas.openxmlformats.org/officeDocument/2006/math">
                     <m:oMathParaPr>
@@ -5104,7 +5508,7 @@
             </p:txBody>
           </p:sp>
         </mc:Choice>
-        <mc:Fallback>
+        <mc:Fallback xmlns="">
           <p:sp>
             <p:nvSpPr>
               <p:cNvPr id="4" name="TextBox 3">
@@ -5149,8 +5553,8 @@
           </p:sp>
         </mc:Fallback>
       </mc:AlternateContent>
-      <mc:AlternateContent xmlns:mc="http://schemas.openxmlformats.org/markup-compatibility/2006">
-        <mc:Choice xmlns:a14="http://schemas.microsoft.com/office/drawing/2010/main" Requires="a14">
+      <mc:AlternateContent xmlns:mc="http://schemas.openxmlformats.org/markup-compatibility/2006" xmlns:a14="http://schemas.microsoft.com/office/drawing/2010/main">
+        <mc:Choice Requires="a14">
           <p:sp>
             <p:nvSpPr>
               <p:cNvPr id="5" name="TextBox 4">
@@ -5179,6 +5583,7 @@
               </a:bodyPr>
               <a:lstStyle/>
               <a:p>
+                <a:pPr/>
                 <a14:m>
                   <m:oMathPara xmlns:m="http://schemas.openxmlformats.org/officeDocument/2006/math">
                     <m:oMathParaPr>
@@ -5360,7 +5765,7 @@
             </p:txBody>
           </p:sp>
         </mc:Choice>
-        <mc:Fallback>
+        <mc:Fallback xmlns="">
           <p:sp>
             <p:nvSpPr>
               <p:cNvPr id="5" name="TextBox 4">
@@ -5405,8 +5810,8 @@
           </p:sp>
         </mc:Fallback>
       </mc:AlternateContent>
-      <mc:AlternateContent xmlns:mc="http://schemas.openxmlformats.org/markup-compatibility/2006">
-        <mc:Choice xmlns:a14="http://schemas.microsoft.com/office/drawing/2010/main" Requires="a14">
+      <mc:AlternateContent xmlns:mc="http://schemas.openxmlformats.org/markup-compatibility/2006" xmlns:a14="http://schemas.microsoft.com/office/drawing/2010/main">
+        <mc:Choice Requires="a14">
           <p:sp>
             <p:nvSpPr>
               <p:cNvPr id="7" name="TextBox 6">
@@ -5513,7 +5918,7 @@
             </p:txBody>
           </p:sp>
         </mc:Choice>
-        <mc:Fallback>
+        <mc:Fallback xmlns="">
           <p:sp>
             <p:nvSpPr>
               <p:cNvPr id="7" name="TextBox 6">
@@ -5682,8 +6087,8 @@
           </a:p>
         </p:txBody>
       </p:sp>
-      <mc:AlternateContent xmlns:mc="http://schemas.openxmlformats.org/markup-compatibility/2006">
-        <mc:Choice xmlns:a14="http://schemas.microsoft.com/office/drawing/2010/main" Requires="a14">
+      <mc:AlternateContent xmlns:mc="http://schemas.openxmlformats.org/markup-compatibility/2006" xmlns:a14="http://schemas.microsoft.com/office/drawing/2010/main">
+        <mc:Choice Requires="a14">
           <p:sp>
             <p:nvSpPr>
               <p:cNvPr id="3" name="Content Placeholder 2">
@@ -5890,7 +6295,7 @@
             </p:txBody>
           </p:sp>
         </mc:Choice>
-        <mc:Fallback>
+        <mc:Fallback xmlns="">
           <p:sp>
             <p:nvSpPr>
               <p:cNvPr id="3" name="Content Placeholder 2">
@@ -6018,8 +6423,8 @@
           </a:p>
         </p:txBody>
       </p:sp>
-      <mc:AlternateContent xmlns:mc="http://schemas.openxmlformats.org/markup-compatibility/2006">
-        <mc:Choice xmlns:a14="http://schemas.microsoft.com/office/drawing/2010/main" Requires="a14">
+      <mc:AlternateContent xmlns:mc="http://schemas.openxmlformats.org/markup-compatibility/2006" xmlns:a14="http://schemas.microsoft.com/office/drawing/2010/main">
+        <mc:Choice Requires="a14">
           <p:sp>
             <p:nvSpPr>
               <p:cNvPr id="3" name="Content Placeholder 2">
@@ -6239,7 +6644,7 @@
             </p:txBody>
           </p:sp>
         </mc:Choice>
-        <mc:Fallback>
+        <mc:Fallback xmlns="">
           <p:sp>
             <p:nvSpPr>
               <p:cNvPr id="3" name="Content Placeholder 2">
@@ -6279,8 +6684,8 @@
           </p:sp>
         </mc:Fallback>
       </mc:AlternateContent>
-      <mc:AlternateContent xmlns:mc="http://schemas.openxmlformats.org/markup-compatibility/2006">
-        <mc:Choice xmlns:a14="http://schemas.microsoft.com/office/drawing/2010/main" Requires="a14">
+      <mc:AlternateContent xmlns:mc="http://schemas.openxmlformats.org/markup-compatibility/2006" xmlns:a14="http://schemas.microsoft.com/office/drawing/2010/main">
+        <mc:Choice Requires="a14">
           <p:sp>
             <p:nvSpPr>
               <p:cNvPr id="4" name="TextBox 3">
@@ -6309,6 +6714,7 @@
               </a:bodyPr>
               <a:lstStyle/>
               <a:p>
+                <a:pPr/>
                 <a14:m>
                   <m:oMathPara xmlns:m="http://schemas.openxmlformats.org/officeDocument/2006/math">
                     <m:oMathParaPr>
@@ -6518,7 +6924,7 @@
             </p:txBody>
           </p:sp>
         </mc:Choice>
-        <mc:Fallback>
+        <mc:Fallback xmlns="">
           <p:sp>
             <p:nvSpPr>
               <p:cNvPr id="4" name="TextBox 3">
@@ -6563,8 +6969,8 @@
           </p:sp>
         </mc:Fallback>
       </mc:AlternateContent>
-      <mc:AlternateContent xmlns:mc="http://schemas.openxmlformats.org/markup-compatibility/2006">
-        <mc:Choice xmlns:a14="http://schemas.microsoft.com/office/drawing/2010/main" Requires="a14">
+      <mc:AlternateContent xmlns:mc="http://schemas.openxmlformats.org/markup-compatibility/2006" xmlns:a14="http://schemas.microsoft.com/office/drawing/2010/main">
+        <mc:Choice Requires="a14">
           <p:sp>
             <p:nvSpPr>
               <p:cNvPr id="5" name="TextBox 4">
@@ -6593,6 +6999,7 @@
               </a:bodyPr>
               <a:lstStyle/>
               <a:p>
+                <a:pPr/>
                 <a14:m>
                   <m:oMathPara xmlns:m="http://schemas.openxmlformats.org/officeDocument/2006/math">
                     <m:oMathParaPr>
@@ -6790,7 +7197,7 @@
             </p:txBody>
           </p:sp>
         </mc:Choice>
-        <mc:Fallback>
+        <mc:Fallback xmlns="">
           <p:sp>
             <p:nvSpPr>
               <p:cNvPr id="5" name="TextBox 4">
@@ -6945,8 +7352,8 @@
           </a:p>
         </p:txBody>
       </p:sp>
-      <mc:AlternateContent xmlns:mc="http://schemas.openxmlformats.org/markup-compatibility/2006">
-        <mc:Choice xmlns:a14="http://schemas.microsoft.com/office/drawing/2010/main" Requires="a14">
+      <mc:AlternateContent xmlns:mc="http://schemas.openxmlformats.org/markup-compatibility/2006" xmlns:a14="http://schemas.microsoft.com/office/drawing/2010/main">
+        <mc:Choice Requires="a14">
           <p:sp>
             <p:nvSpPr>
               <p:cNvPr id="5" name="TextBox 4">
@@ -6975,6 +7382,7 @@
               </a:bodyPr>
               <a:lstStyle/>
               <a:p>
+                <a:pPr/>
                 <a14:m>
                   <m:oMathPara xmlns:m="http://schemas.openxmlformats.org/officeDocument/2006/math">
                     <m:oMathParaPr>
@@ -7106,7 +7514,7 @@
             </p:txBody>
           </p:sp>
         </mc:Choice>
-        <mc:Fallback>
+        <mc:Fallback xmlns="">
           <p:sp>
             <p:nvSpPr>
               <p:cNvPr id="5" name="TextBox 4">
@@ -7151,8 +7559,8 @@
           </p:sp>
         </mc:Fallback>
       </mc:AlternateContent>
-      <mc:AlternateContent xmlns:mc="http://schemas.openxmlformats.org/markup-compatibility/2006">
-        <mc:Choice xmlns:a14="http://schemas.microsoft.com/office/drawing/2010/main" Requires="a14">
+      <mc:AlternateContent xmlns:mc="http://schemas.openxmlformats.org/markup-compatibility/2006" xmlns:a14="http://schemas.microsoft.com/office/drawing/2010/main">
+        <mc:Choice Requires="a14">
           <p:sp>
             <p:nvSpPr>
               <p:cNvPr id="7" name="TextBox 6">
@@ -7181,6 +7589,7 @@
               </a:bodyPr>
               <a:lstStyle/>
               <a:p>
+                <a:pPr/>
                 <a14:m>
                   <m:oMathPara xmlns:m="http://schemas.openxmlformats.org/officeDocument/2006/math">
                     <m:oMathParaPr>
@@ -7388,7 +7797,7 @@
             </p:txBody>
           </p:sp>
         </mc:Choice>
-        <mc:Fallback>
+        <mc:Fallback xmlns="">
           <p:sp>
             <p:nvSpPr>
               <p:cNvPr id="7" name="TextBox 6">
@@ -7433,8 +7842,8 @@
           </p:sp>
         </mc:Fallback>
       </mc:AlternateContent>
-      <mc:AlternateContent xmlns:mc="http://schemas.openxmlformats.org/markup-compatibility/2006">
-        <mc:Choice xmlns:a14="http://schemas.microsoft.com/office/drawing/2010/main" Requires="a14">
+      <mc:AlternateContent xmlns:mc="http://schemas.openxmlformats.org/markup-compatibility/2006" xmlns:a14="http://schemas.microsoft.com/office/drawing/2010/main">
+        <mc:Choice Requires="a14">
           <p:sp>
             <p:nvSpPr>
               <p:cNvPr id="8" name="TextBox 7">
@@ -7463,6 +7872,7 @@
               </a:bodyPr>
               <a:lstStyle/>
               <a:p>
+                <a:pPr/>
                 <a14:m>
                   <m:oMathPara xmlns:m="http://schemas.openxmlformats.org/officeDocument/2006/math">
                     <m:oMathParaPr>
@@ -7667,7 +8077,7 @@
             </p:txBody>
           </p:sp>
         </mc:Choice>
-        <mc:Fallback>
+        <mc:Fallback xmlns="">
           <p:sp>
             <p:nvSpPr>
               <p:cNvPr id="8" name="TextBox 7">
@@ -7808,8 +8218,8 @@
           </a:p>
         </p:txBody>
       </p:sp>
-      <mc:AlternateContent xmlns:mc="http://schemas.openxmlformats.org/markup-compatibility/2006">
-        <mc:Choice xmlns:a14="http://schemas.microsoft.com/office/drawing/2010/main" Requires="a14">
+      <mc:AlternateContent xmlns:mc="http://schemas.openxmlformats.org/markup-compatibility/2006" xmlns:a14="http://schemas.microsoft.com/office/drawing/2010/main">
+        <mc:Choice Requires="a14">
           <p:sp>
             <p:nvSpPr>
               <p:cNvPr id="3" name="Content Placeholder 2">
@@ -7937,7 +8347,7 @@
             </p:txBody>
           </p:sp>
         </mc:Choice>
-        <mc:Fallback>
+        <mc:Fallback xmlns="">
           <p:sp>
             <p:nvSpPr>
               <p:cNvPr id="3" name="Content Placeholder 2">
@@ -8240,39 +8650,6 @@
           <a:chExt cx="0" cy="0"/>
         </a:xfrm>
       </p:grpSpPr>
-      <p:pic>
-        <p:nvPicPr>
-          <p:cNvPr id="6" name="Content Placeholder 5">
-            <a:extLst>
-              <a:ext uri="{FF2B5EF4-FFF2-40B4-BE49-F238E27FC236}">
-                <a16:creationId xmlns:a16="http://schemas.microsoft.com/office/drawing/2014/main" id="{EB973ADB-FA5B-EF69-5654-23330406A0B1}"/>
-              </a:ext>
-            </a:extLst>
-          </p:cNvPr>
-          <p:cNvPicPr>
-            <a:picLocks noGrp="1" noChangeAspect="1"/>
-          </p:cNvPicPr>
-          <p:nvPr>
-            <p:ph idx="1"/>
-          </p:nvPr>
-        </p:nvPicPr>
-        <p:blipFill>
-          <a:blip r:embed="rId2"/>
-          <a:srcRect b="11683"/>
-          <a:stretch>
-            <a:fillRect/>
-          </a:stretch>
-        </p:blipFill>
-        <p:spPr>
-          <a:xfrm>
-            <a:off x="275" y="935923"/>
-            <a:ext cx="4770808" cy="4907718"/>
-          </a:xfrm>
-          <a:prstGeom prst="rect">
-            <a:avLst/>
-          </a:prstGeom>
-        </p:spPr>
-      </p:pic>
       <p:sp>
         <p:nvSpPr>
           <p:cNvPr id="2" name="Title 1">
@@ -8296,7 +8673,7 @@
           <a:p>
             <a:r>
               <a:rPr lang="en-US" dirty="0"/>
-              <a:t>2D Transient Poisson</a:t>
+              <a:t>2D Transient Poisson – Boundary integral </a:t>
             </a:r>
           </a:p>
         </p:txBody>
@@ -8316,21 +8693,65 @@
           <p:nvPr/>
         </p:nvPicPr>
         <p:blipFill>
-          <a:blip r:embed="rId3"/>
+          <a:blip r:embed="rId2"/>
           <a:stretch>
             <a:fillRect/>
           </a:stretch>
         </p:blipFill>
         <p:spPr>
           <a:xfrm>
-            <a:off x="2805505" y="5752946"/>
-            <a:ext cx="6049219" cy="1105054"/>
+            <a:off x="1885386" y="1334856"/>
+            <a:ext cx="8849350" cy="1616574"/>
           </a:xfrm>
           <a:prstGeom prst="rect">
             <a:avLst/>
           </a:prstGeom>
         </p:spPr>
       </p:pic>
+      <p:sp>
+        <p:nvSpPr>
+          <p:cNvPr id="5" name="TextBox 4">
+            <a:extLst>
+              <a:ext uri="{FF2B5EF4-FFF2-40B4-BE49-F238E27FC236}">
+                <a16:creationId xmlns:a16="http://schemas.microsoft.com/office/drawing/2014/main" id="{53715613-9A90-3F2D-9868-4FE05B55878D}"/>
+              </a:ext>
+            </a:extLst>
+          </p:cNvPr>
+          <p:cNvSpPr txBox="1"/>
+          <p:nvPr/>
+        </p:nvSpPr>
+        <p:spPr>
+          <a:xfrm>
+            <a:off x="371192" y="3032911"/>
+            <a:ext cx="11986788" cy="646331"/>
+          </a:xfrm>
+          <a:prstGeom prst="rect">
+            <a:avLst/>
+          </a:prstGeom>
+          <a:noFill/>
+        </p:spPr>
+        <p:txBody>
+          <a:bodyPr wrap="square" rtlCol="0">
+            <a:spAutoFit/>
+          </a:bodyPr>
+          <a:lstStyle/>
+          <a:p>
+            <a:pPr marL="285750" indent="-285750">
+              <a:buFont typeface="Arial" panose="020B0604020202020204" pitchFamily="34" charset="0"/>
+              <a:buChar char="•"/>
+            </a:pPr>
+            <a:r>
+              <a:rPr lang="en-US" sz="3600" dirty="0"/>
+              <a:t>Boundary integral on a node is sum of </a:t>
+            </a:r>
+            <a:r>
+              <a:rPr lang="en-US" sz="3600"/>
+              <a:t>neighbor elements</a:t>
+            </a:r>
+            <a:endParaRPr lang="en-US" sz="3600" dirty="0"/>
+          </a:p>
+        </p:txBody>
+      </p:sp>
     </p:spTree>
     <p:extLst>
       <p:ext uri="{BB962C8B-B14F-4D97-AF65-F5344CB8AC3E}">

</xml_diff>